<commit_message>
cambios clases 2 y 3
</commit_message>
<xml_diff>
--- a/Clase 2 - EPH e Intro a Tidyverse/Presentación EPH.pptx
+++ b/Clase 2 - EPH e Intro a Tidyverse/Presentación EPH.pptx
@@ -5,7 +5,7 @@
     <p:sldMasterId id="2147483696" r:id="rId4"/>
   </p:sldMasterIdLst>
   <p:notesMasterIdLst>
-    <p:notesMasterId r:id="rId24"/>
+    <p:notesMasterId r:id="rId28"/>
   </p:notesMasterIdLst>
   <p:sldIdLst>
     <p:sldId id="459" r:id="rId5"/>
@@ -27,6 +27,10 @@
     <p:sldId id="353" r:id="rId21"/>
     <p:sldId id="281" r:id="rId22"/>
     <p:sldId id="371" r:id="rId23"/>
+    <p:sldId id="481" r:id="rId24"/>
+    <p:sldId id="484" r:id="rId25"/>
+    <p:sldId id="482" r:id="rId26"/>
+    <p:sldId id="483" r:id="rId27"/>
   </p:sldIdLst>
   <p:sldSz cx="12192000" cy="6858000"/>
   <p:notesSz cx="6858000" cy="9144000"/>
@@ -215,7 +219,7 @@
           <a:p>
             <a:fld id="{30269C05-07A3-4C0B-B452-D73BEED39343}" type="datetimeFigureOut">
               <a:rPr lang="es-ES" smtClean="0"/>
-              <a:t>05/11/2024</a:t>
+              <a:t>30/04/2026</a:t>
             </a:fld>
             <a:endParaRPr lang="es-ES"/>
           </a:p>
@@ -536,6 +540,13 @@
             <a:schemeClr val="lt1"/>
           </a:fontRef>
         </p:style>
+        <p:txBody>
+          <a:bodyPr/>
+          <a:lstStyle/>
+          <a:p>
+            <a:endParaRPr lang="es-AR"/>
+          </a:p>
+        </p:txBody>
       </p:sp>
       <p:sp>
         <p:nvSpPr>
@@ -574,6 +585,13 @@
             <a:schemeClr val="lt1"/>
           </a:fontRef>
         </p:style>
+        <p:txBody>
+          <a:bodyPr/>
+          <a:lstStyle/>
+          <a:p>
+            <a:endParaRPr lang="es-AR"/>
+          </a:p>
+        </p:txBody>
       </p:sp>
       <p:sp>
         <p:nvSpPr>
@@ -708,7 +726,7 @@
           <a:p>
             <a:fld id="{1B3EF8C8-B97B-4B8B-89DD-60B674DEC85F}" type="datetime4">
               <a:rPr lang="es-ES" smtClean="0"/>
-              <a:t>5 de noviembre de 2024</a:t>
+              <a:t>30 de abril de 2026</a:t>
             </a:fld>
             <a:endParaRPr lang="en-US"/>
           </a:p>
@@ -917,7 +935,7 @@
           <a:p>
             <a:fld id="{1B3EF8C8-B97B-4B8B-89DD-60B674DEC85F}" type="datetime4">
               <a:rPr lang="es-ES" smtClean="0"/>
-              <a:t>5 de noviembre de 2024</a:t>
+              <a:t>30 de abril de 2026</a:t>
             </a:fld>
             <a:endParaRPr lang="en-US"/>
           </a:p>
@@ -1174,7 +1192,7 @@
           <a:p>
             <a:fld id="{1B3EF8C8-B97B-4B8B-89DD-60B674DEC85F}" type="datetime4">
               <a:rPr lang="es-ES" smtClean="0"/>
-              <a:t>5 de noviembre de 2024</a:t>
+              <a:t>30 de abril de 2026</a:t>
             </a:fld>
             <a:endParaRPr lang="en-US"/>
           </a:p>
@@ -1349,7 +1367,7 @@
           <a:p>
             <a:fld id="{1B3EF8C8-B97B-4B8B-89DD-60B674DEC85F}" type="datetime4">
               <a:rPr lang="es-ES" smtClean="0"/>
-              <a:t>5 de noviembre de 2024</a:t>
+              <a:t>30 de abril de 2026</a:t>
             </a:fld>
             <a:endParaRPr lang="en-US"/>
           </a:p>
@@ -1693,7 +1711,7 @@
           <a:p>
             <a:fld id="{1B3EF8C8-B97B-4B8B-89DD-60B674DEC85F}" type="datetime4">
               <a:rPr lang="es-ES" smtClean="0"/>
-              <a:t>5 de noviembre de 2024</a:t>
+              <a:t>30 de abril de 2026</a:t>
             </a:fld>
             <a:endParaRPr lang="en-US"/>
           </a:p>
@@ -1969,7 +1987,7 @@
           <a:p>
             <a:fld id="{1B3EF8C8-B97B-4B8B-89DD-60B674DEC85F}" type="datetime4">
               <a:rPr lang="es-ES" smtClean="0"/>
-              <a:t>5 de noviembre de 2024</a:t>
+              <a:t>30 de abril de 2026</a:t>
             </a:fld>
             <a:endParaRPr lang="en-US"/>
           </a:p>
@@ -2349,7 +2367,7 @@
           <a:p>
             <a:fld id="{1B3EF8C8-B97B-4B8B-89DD-60B674DEC85F}" type="datetime4">
               <a:rPr lang="es-ES" smtClean="0"/>
-              <a:t>5 de noviembre de 2024</a:t>
+              <a:t>30 de abril de 2026</a:t>
             </a:fld>
             <a:endParaRPr lang="en-US"/>
           </a:p>
@@ -2468,7 +2486,7 @@
           <a:p>
             <a:fld id="{1B3EF8C8-B97B-4B8B-89DD-60B674DEC85F}" type="datetime4">
               <a:rPr lang="es-ES" smtClean="0"/>
-              <a:t>5 de noviembre de 2024</a:t>
+              <a:t>30 de abril de 2026</a:t>
             </a:fld>
             <a:endParaRPr lang="en-US"/>
           </a:p>
@@ -2640,7 +2658,7 @@
           <a:p>
             <a:fld id="{1B3EF8C8-B97B-4B8B-89DD-60B674DEC85F}" type="datetime4">
               <a:rPr lang="es-ES" smtClean="0"/>
-              <a:t>5 de noviembre de 2024</a:t>
+              <a:t>30 de abril de 2026</a:t>
             </a:fld>
             <a:endParaRPr lang="en-US"/>
           </a:p>
@@ -2995,7 +3013,7 @@
           <a:p>
             <a:fld id="{1B3EF8C8-B97B-4B8B-89DD-60B674DEC85F}" type="datetime4">
               <a:rPr lang="es-ES" smtClean="0"/>
-              <a:t>5 de noviembre de 2024</a:t>
+              <a:t>30 de abril de 2026</a:t>
             </a:fld>
             <a:endParaRPr lang="en-US"/>
           </a:p>
@@ -3378,7 +3396,7 @@
           <a:p>
             <a:fld id="{1B3EF8C8-B97B-4B8B-89DD-60B674DEC85F}" type="datetime4">
               <a:rPr lang="es-ES" smtClean="0"/>
-              <a:t>5 de noviembre de 2024</a:t>
+              <a:t>30 de abril de 2026</a:t>
             </a:fld>
             <a:endParaRPr lang="en-US"/>
           </a:p>
@@ -3499,6 +3517,13 @@
             <a:schemeClr val="lt1"/>
           </a:fontRef>
         </p:style>
+        <p:txBody>
+          <a:bodyPr/>
+          <a:lstStyle/>
+          <a:p>
+            <a:endParaRPr lang="es-AR"/>
+          </a:p>
+        </p:txBody>
       </p:sp>
       <p:sp>
         <p:nvSpPr>
@@ -3537,6 +3562,13 @@
             <a:schemeClr val="lt1"/>
           </a:fontRef>
         </p:style>
+        <p:txBody>
+          <a:bodyPr/>
+          <a:lstStyle/>
+          <a:p>
+            <a:endParaRPr lang="es-AR"/>
+          </a:p>
+        </p:txBody>
       </p:sp>
       <p:sp>
         <p:nvSpPr>
@@ -3666,7 +3698,7 @@
           <a:p>
             <a:fld id="{1B3EF8C8-B97B-4B8B-89DD-60B674DEC85F}" type="datetime4">
               <a:rPr lang="es-ES" smtClean="0"/>
-              <a:t>5 de noviembre de 2024</a:t>
+              <a:t>30 de abril de 2026</a:t>
             </a:fld>
             <a:endParaRPr lang="en-US"/>
           </a:p>
@@ -4220,40 +4252,21 @@
               </a:lnSpc>
             </a:pPr>
             <a:r>
+              <a:rPr lang="es-ES" sz="2800" b="1" dirty="0">
+                <a:latin typeface="Garamond" panose="02020404030301010803" pitchFamily="18" charset="0"/>
+                <a:ea typeface="Times New Roman" panose="02020603050405020304" pitchFamily="18" charset="0"/>
+                <a:cs typeface="Arial" panose="020B0604020202020204" pitchFamily="34" charset="0"/>
+              </a:rPr>
+              <a:t>Programación y visualización en estadísticas laborales 2026 - ASET</a:t>
+            </a:r>
+            <a:r>
               <a:rPr lang="es-MX" sz="2800" b="1" dirty="0">
                 <a:effectLst/>
                 <a:latin typeface="Garamond" panose="02020404030301010803" pitchFamily="18" charset="0"/>
                 <a:ea typeface="Times New Roman" panose="02020603050405020304" pitchFamily="18" charset="0"/>
                 <a:cs typeface="Arial" panose="020B0604020202020204" pitchFamily="34" charset="0"/>
               </a:rPr>
-              <a:t>Herramientas de programación para la producción y difusión de estadísticas socioeconómicas. </a:t>
-            </a:r>
-            <a:r>
-              <a:rPr lang="es-MX" sz="2800" dirty="0">
-                <a:effectLst/>
-                <a:latin typeface="Garamond" panose="02020404030301010803" pitchFamily="18" charset="0"/>
-                <a:ea typeface="Times New Roman" panose="02020603050405020304" pitchFamily="18" charset="0"/>
-                <a:cs typeface="Arial" panose="020B0604020202020204" pitchFamily="34" charset="0"/>
-              </a:rPr>
-              <a:t>Procesamiento con Software “R” y armado de tableros con PowerBI y </a:t>
-            </a:r>
-            <a:r>
-              <a:rPr lang="es-MX" sz="2800" dirty="0" err="1">
-                <a:effectLst/>
-                <a:latin typeface="Garamond" panose="02020404030301010803" pitchFamily="18" charset="0"/>
-                <a:ea typeface="Times New Roman" panose="02020603050405020304" pitchFamily="18" charset="0"/>
-                <a:cs typeface="Arial" panose="020B0604020202020204" pitchFamily="34" charset="0"/>
-              </a:rPr>
-              <a:t>Looker</a:t>
-            </a:r>
-            <a:r>
-              <a:rPr lang="es-MX" sz="2800" dirty="0">
-                <a:effectLst/>
-                <a:latin typeface="Garamond" panose="02020404030301010803" pitchFamily="18" charset="0"/>
-                <a:ea typeface="Times New Roman" panose="02020603050405020304" pitchFamily="18" charset="0"/>
-                <a:cs typeface="Arial" panose="020B0604020202020204" pitchFamily="34" charset="0"/>
-              </a:rPr>
-              <a:t> Studio</a:t>
+              <a:t>. </a:t>
             </a:r>
             <a:endParaRPr lang="es-AR" sz="2800" dirty="0">
               <a:effectLst/>
@@ -7342,7 +7355,7 @@
                           </a:solidFill>
                           <a:latin typeface="Cambria Math" panose="02040503050406030204" pitchFamily="18" charset="0"/>
                         </a:rPr>
-                        <m:t>𝑎𝑐𝑡𝑖𝑣𝑖𝑑</m:t>
+                        <m:t>𝑎𝑐𝑡𝑖𝑣𝑖𝑑𝑎</m:t>
                       </m:r>
                       <m:r>
                         <a:rPr lang="es-AR" i="1">
@@ -7351,7 +7364,7 @@
                           </a:solidFill>
                           <a:latin typeface="Cambria Math" panose="02040503050406030204" pitchFamily="18" charset="0"/>
                         </a:rPr>
-                        <m:t>𝑎𝑑</m:t>
+                        <m:t>𝑑</m:t>
                       </m:r>
                       <m:r>
                         <a:rPr lang="es-AR" i="1">
@@ -10119,6 +10132,412 @@
 </p:sld>
 </file>
 
+<file path=ppt/slides/slide20.xml><?xml version="1.0" encoding="utf-8"?>
+<p:sld xmlns:a="http://schemas.openxmlformats.org/drawingml/2006/main" xmlns:r="http://schemas.openxmlformats.org/officeDocument/2006/relationships" xmlns:p="http://schemas.openxmlformats.org/presentationml/2006/main">
+  <p:cSld>
+    <p:spTree>
+      <p:nvGrpSpPr>
+        <p:cNvPr id="1" name="">
+          <a:extLst>
+            <a:ext uri="{FF2B5EF4-FFF2-40B4-BE49-F238E27FC236}">
+              <a16:creationId xmlns:a16="http://schemas.microsoft.com/office/drawing/2014/main" id="{B222ADE4-F48C-E63C-1102-B06D1EBE467C}"/>
+            </a:ext>
+          </a:extLst>
+        </p:cNvPr>
+        <p:cNvGrpSpPr/>
+        <p:nvPr/>
+      </p:nvGrpSpPr>
+      <p:grpSpPr>
+        <a:xfrm>
+          <a:off x="0" y="0"/>
+          <a:ext cx="0" cy="0"/>
+          <a:chOff x="0" y="0"/>
+          <a:chExt cx="0" cy="0"/>
+        </a:xfrm>
+      </p:grpSpPr>
+      <p:sp>
+        <p:nvSpPr>
+          <p:cNvPr id="2" name="Título 1">
+            <a:extLst>
+              <a:ext uri="{FF2B5EF4-FFF2-40B4-BE49-F238E27FC236}">
+                <a16:creationId xmlns:a16="http://schemas.microsoft.com/office/drawing/2014/main" id="{B68B2224-C6C1-5D27-10AC-A2CC83D362F2}"/>
+              </a:ext>
+            </a:extLst>
+          </p:cNvPr>
+          <p:cNvSpPr>
+            <a:spLocks noGrp="1"/>
+          </p:cNvSpPr>
+          <p:nvPr>
+            <p:ph type="title"/>
+          </p:nvPr>
+        </p:nvSpPr>
+        <p:spPr>
+          <a:xfrm>
+            <a:off x="1724000" y="-10254"/>
+            <a:ext cx="7620000" cy="1143000"/>
+          </a:xfrm>
+        </p:spPr>
+        <p:txBody>
+          <a:bodyPr/>
+          <a:lstStyle/>
+          <a:p>
+            <a:r>
+              <a:rPr lang="es-ES" sz="4000" dirty="0"/>
+              <a:t>Distinción según formalidad (empleo y sector)</a:t>
+            </a:r>
+            <a:endParaRPr lang="es-AR" sz="4000" dirty="0"/>
+          </a:p>
+        </p:txBody>
+      </p:sp>
+      <p:pic>
+        <p:nvPicPr>
+          <p:cNvPr id="11" name="Imagen 10">
+            <a:extLst>
+              <a:ext uri="{FF2B5EF4-FFF2-40B4-BE49-F238E27FC236}">
+                <a16:creationId xmlns:a16="http://schemas.microsoft.com/office/drawing/2014/main" id="{054E950D-7963-E3EE-943D-2EABECDC474D}"/>
+              </a:ext>
+            </a:extLst>
+          </p:cNvPr>
+          <p:cNvPicPr>
+            <a:picLocks noChangeAspect="1"/>
+          </p:cNvPicPr>
+          <p:nvPr/>
+        </p:nvPicPr>
+        <p:blipFill>
+          <a:blip r:embed="rId2"/>
+          <a:stretch>
+            <a:fillRect/>
+          </a:stretch>
+        </p:blipFill>
+        <p:spPr>
+          <a:xfrm>
+            <a:off x="1724000" y="1268761"/>
+            <a:ext cx="7620000" cy="5441509"/>
+          </a:xfrm>
+          <a:prstGeom prst="rect">
+            <a:avLst/>
+          </a:prstGeom>
+        </p:spPr>
+      </p:pic>
+    </p:spTree>
+    <p:extLst>
+      <p:ext uri="{BB962C8B-B14F-4D97-AF65-F5344CB8AC3E}">
+        <p14:creationId xmlns:p14="http://schemas.microsoft.com/office/powerpoint/2010/main" val="367111989"/>
+      </p:ext>
+    </p:extLst>
+  </p:cSld>
+  <p:clrMapOvr>
+    <a:masterClrMapping/>
+  </p:clrMapOvr>
+</p:sld>
+</file>
+
+<file path=ppt/slides/slide21.xml><?xml version="1.0" encoding="utf-8"?>
+<p:sld xmlns:a="http://schemas.openxmlformats.org/drawingml/2006/main" xmlns:r="http://schemas.openxmlformats.org/officeDocument/2006/relationships" xmlns:p="http://schemas.openxmlformats.org/presentationml/2006/main">
+  <p:cSld>
+    <p:spTree>
+      <p:nvGrpSpPr>
+        <p:cNvPr id="1" name="">
+          <a:extLst>
+            <a:ext uri="{FF2B5EF4-FFF2-40B4-BE49-F238E27FC236}">
+              <a16:creationId xmlns:a16="http://schemas.microsoft.com/office/drawing/2014/main" id="{8739AB82-1FA2-B010-00D6-52DE6163DEDD}"/>
+            </a:ext>
+          </a:extLst>
+        </p:cNvPr>
+        <p:cNvGrpSpPr/>
+        <p:nvPr/>
+      </p:nvGrpSpPr>
+      <p:grpSpPr>
+        <a:xfrm>
+          <a:off x="0" y="0"/>
+          <a:ext cx="0" cy="0"/>
+          <a:chOff x="0" y="0"/>
+          <a:chExt cx="0" cy="0"/>
+        </a:xfrm>
+      </p:grpSpPr>
+      <p:pic>
+        <p:nvPicPr>
+          <p:cNvPr id="3" name="Imagen 2">
+            <a:extLst>
+              <a:ext uri="{FF2B5EF4-FFF2-40B4-BE49-F238E27FC236}">
+                <a16:creationId xmlns:a16="http://schemas.microsoft.com/office/drawing/2014/main" id="{6D39F816-761E-2922-0340-382D2C4523FC}"/>
+              </a:ext>
+            </a:extLst>
+          </p:cNvPr>
+          <p:cNvPicPr>
+            <a:picLocks noChangeAspect="1"/>
+          </p:cNvPicPr>
+          <p:nvPr/>
+        </p:nvPicPr>
+        <p:blipFill>
+          <a:blip r:embed="rId2"/>
+          <a:stretch>
+            <a:fillRect/>
+          </a:stretch>
+        </p:blipFill>
+        <p:spPr>
+          <a:xfrm>
+            <a:off x="2567608" y="272063"/>
+            <a:ext cx="6332018" cy="6313875"/>
+          </a:xfrm>
+          <a:prstGeom prst="rect">
+            <a:avLst/>
+          </a:prstGeom>
+        </p:spPr>
+      </p:pic>
+      <p:sp>
+        <p:nvSpPr>
+          <p:cNvPr id="4" name="CuadroTexto 3">
+            <a:extLst>
+              <a:ext uri="{FF2B5EF4-FFF2-40B4-BE49-F238E27FC236}">
+                <a16:creationId xmlns:a16="http://schemas.microsoft.com/office/drawing/2014/main" id="{E00E585F-5F25-29A3-5FD1-7F8C75DDA795}"/>
+              </a:ext>
+            </a:extLst>
+          </p:cNvPr>
+          <p:cNvSpPr txBox="1"/>
+          <p:nvPr/>
+        </p:nvSpPr>
+        <p:spPr>
+          <a:xfrm>
+            <a:off x="1631504" y="0"/>
+            <a:ext cx="4572000" cy="369332"/>
+          </a:xfrm>
+          <a:prstGeom prst="rect">
+            <a:avLst/>
+          </a:prstGeom>
+          <a:noFill/>
+        </p:spPr>
+        <p:txBody>
+          <a:bodyPr wrap="square">
+            <a:spAutoFit/>
+          </a:bodyPr>
+          <a:lstStyle/>
+          <a:p>
+            <a:r>
+              <a:rPr lang="es-AR" b="1" dirty="0"/>
+              <a:t>Informalidad (Sector/Empleo)</a:t>
+            </a:r>
+            <a:endParaRPr lang="es-AR" dirty="0"/>
+          </a:p>
+        </p:txBody>
+      </p:sp>
+    </p:spTree>
+    <p:extLst>
+      <p:ext uri="{BB962C8B-B14F-4D97-AF65-F5344CB8AC3E}">
+        <p14:creationId xmlns:p14="http://schemas.microsoft.com/office/powerpoint/2010/main" val="1705180333"/>
+      </p:ext>
+    </p:extLst>
+  </p:cSld>
+  <p:clrMapOvr>
+    <a:masterClrMapping/>
+  </p:clrMapOvr>
+</p:sld>
+</file>
+
+<file path=ppt/slides/slide22.xml><?xml version="1.0" encoding="utf-8"?>
+<p:sld xmlns:a="http://schemas.openxmlformats.org/drawingml/2006/main" xmlns:r="http://schemas.openxmlformats.org/officeDocument/2006/relationships" xmlns:p="http://schemas.openxmlformats.org/presentationml/2006/main">
+  <p:cSld>
+    <p:spTree>
+      <p:nvGrpSpPr>
+        <p:cNvPr id="1" name="">
+          <a:extLst>
+            <a:ext uri="{FF2B5EF4-FFF2-40B4-BE49-F238E27FC236}">
+              <a16:creationId xmlns:a16="http://schemas.microsoft.com/office/drawing/2014/main" id="{2CE7241E-217C-AA33-C0C9-771C79E91D5C}"/>
+            </a:ext>
+          </a:extLst>
+        </p:cNvPr>
+        <p:cNvGrpSpPr/>
+        <p:nvPr/>
+      </p:nvGrpSpPr>
+      <p:grpSpPr>
+        <a:xfrm>
+          <a:off x="0" y="0"/>
+          <a:ext cx="0" cy="0"/>
+          <a:chOff x="0" y="0"/>
+          <a:chExt cx="0" cy="0"/>
+        </a:xfrm>
+      </p:grpSpPr>
+      <p:pic>
+        <p:nvPicPr>
+          <p:cNvPr id="7" name="Imagen 6">
+            <a:extLst>
+              <a:ext uri="{FF2B5EF4-FFF2-40B4-BE49-F238E27FC236}">
+                <a16:creationId xmlns:a16="http://schemas.microsoft.com/office/drawing/2014/main" id="{8180A8C6-080B-BC6A-47EC-6704F12FB782}"/>
+              </a:ext>
+            </a:extLst>
+          </p:cNvPr>
+          <p:cNvPicPr>
+            <a:picLocks noChangeAspect="1"/>
+          </p:cNvPicPr>
+          <p:nvPr/>
+        </p:nvPicPr>
+        <p:blipFill>
+          <a:blip r:embed="rId2"/>
+          <a:stretch>
+            <a:fillRect/>
+          </a:stretch>
+        </p:blipFill>
+        <p:spPr>
+          <a:xfrm>
+            <a:off x="2711624" y="332657"/>
+            <a:ext cx="6336704" cy="6676007"/>
+          </a:xfrm>
+          <a:prstGeom prst="rect">
+            <a:avLst/>
+          </a:prstGeom>
+        </p:spPr>
+      </p:pic>
+      <p:sp>
+        <p:nvSpPr>
+          <p:cNvPr id="11" name="CuadroTexto 10">
+            <a:extLst>
+              <a:ext uri="{FF2B5EF4-FFF2-40B4-BE49-F238E27FC236}">
+                <a16:creationId xmlns:a16="http://schemas.microsoft.com/office/drawing/2014/main" id="{F992CCE9-DBB5-D2B5-EE7F-0EB6BB5C5A75}"/>
+              </a:ext>
+            </a:extLst>
+          </p:cNvPr>
+          <p:cNvSpPr txBox="1"/>
+          <p:nvPr/>
+        </p:nvSpPr>
+        <p:spPr>
+          <a:xfrm>
+            <a:off x="1631504" y="0"/>
+            <a:ext cx="4572000" cy="369332"/>
+          </a:xfrm>
+          <a:prstGeom prst="rect">
+            <a:avLst/>
+          </a:prstGeom>
+          <a:noFill/>
+        </p:spPr>
+        <p:txBody>
+          <a:bodyPr wrap="square">
+            <a:spAutoFit/>
+          </a:bodyPr>
+          <a:lstStyle/>
+          <a:p>
+            <a:r>
+              <a:rPr lang="es-AR" b="1" dirty="0"/>
+              <a:t>Informalidad (Sector/Empleo)</a:t>
+            </a:r>
+            <a:endParaRPr lang="es-AR" dirty="0"/>
+          </a:p>
+        </p:txBody>
+      </p:sp>
+    </p:spTree>
+    <p:extLst>
+      <p:ext uri="{BB962C8B-B14F-4D97-AF65-F5344CB8AC3E}">
+        <p14:creationId xmlns:p14="http://schemas.microsoft.com/office/powerpoint/2010/main" val="491235945"/>
+      </p:ext>
+    </p:extLst>
+  </p:cSld>
+  <p:clrMapOvr>
+    <a:masterClrMapping/>
+  </p:clrMapOvr>
+</p:sld>
+</file>
+
+<file path=ppt/slides/slide23.xml><?xml version="1.0" encoding="utf-8"?>
+<p:sld xmlns:a="http://schemas.openxmlformats.org/drawingml/2006/main" xmlns:r="http://schemas.openxmlformats.org/officeDocument/2006/relationships" xmlns:p="http://schemas.openxmlformats.org/presentationml/2006/main">
+  <p:cSld>
+    <p:spTree>
+      <p:nvGrpSpPr>
+        <p:cNvPr id="1" name="">
+          <a:extLst>
+            <a:ext uri="{FF2B5EF4-FFF2-40B4-BE49-F238E27FC236}">
+              <a16:creationId xmlns:a16="http://schemas.microsoft.com/office/drawing/2014/main" id="{459C8092-217C-1243-1AD2-DA56420D9242}"/>
+            </a:ext>
+          </a:extLst>
+        </p:cNvPr>
+        <p:cNvGrpSpPr/>
+        <p:nvPr/>
+      </p:nvGrpSpPr>
+      <p:grpSpPr>
+        <a:xfrm>
+          <a:off x="0" y="0"/>
+          <a:ext cx="0" cy="0"/>
+          <a:chOff x="0" y="0"/>
+          <a:chExt cx="0" cy="0"/>
+        </a:xfrm>
+      </p:grpSpPr>
+      <p:pic>
+        <p:nvPicPr>
+          <p:cNvPr id="3" name="Imagen 2">
+            <a:extLst>
+              <a:ext uri="{FF2B5EF4-FFF2-40B4-BE49-F238E27FC236}">
+                <a16:creationId xmlns:a16="http://schemas.microsoft.com/office/drawing/2014/main" id="{FAFF162E-B292-BACC-5218-CB579B121391}"/>
+              </a:ext>
+            </a:extLst>
+          </p:cNvPr>
+          <p:cNvPicPr>
+            <a:picLocks noChangeAspect="1"/>
+          </p:cNvPicPr>
+          <p:nvPr/>
+        </p:nvPicPr>
+        <p:blipFill>
+          <a:blip r:embed="rId2"/>
+          <a:stretch>
+            <a:fillRect/>
+          </a:stretch>
+        </p:blipFill>
+        <p:spPr>
+          <a:xfrm>
+            <a:off x="1847528" y="260648"/>
+            <a:ext cx="8012366" cy="6336704"/>
+          </a:xfrm>
+          <a:prstGeom prst="rect">
+            <a:avLst/>
+          </a:prstGeom>
+        </p:spPr>
+      </p:pic>
+      <p:sp>
+        <p:nvSpPr>
+          <p:cNvPr id="4" name="CuadroTexto 3">
+            <a:extLst>
+              <a:ext uri="{FF2B5EF4-FFF2-40B4-BE49-F238E27FC236}">
+                <a16:creationId xmlns:a16="http://schemas.microsoft.com/office/drawing/2014/main" id="{D1BEC7AA-5256-7036-0D2E-40A176DF8BBE}"/>
+              </a:ext>
+            </a:extLst>
+          </p:cNvPr>
+          <p:cNvSpPr txBox="1"/>
+          <p:nvPr/>
+        </p:nvSpPr>
+        <p:spPr>
+          <a:xfrm>
+            <a:off x="1631504" y="0"/>
+            <a:ext cx="4572000" cy="369332"/>
+          </a:xfrm>
+          <a:prstGeom prst="rect">
+            <a:avLst/>
+          </a:prstGeom>
+          <a:noFill/>
+        </p:spPr>
+        <p:txBody>
+          <a:bodyPr wrap="square">
+            <a:spAutoFit/>
+          </a:bodyPr>
+          <a:lstStyle/>
+          <a:p>
+            <a:r>
+              <a:rPr lang="es-AR" b="1" dirty="0"/>
+              <a:t>Informalidad (Sector/Empleo)</a:t>
+            </a:r>
+            <a:endParaRPr lang="es-AR" dirty="0"/>
+          </a:p>
+        </p:txBody>
+      </p:sp>
+    </p:spTree>
+    <p:extLst>
+      <p:ext uri="{BB962C8B-B14F-4D97-AF65-F5344CB8AC3E}">
+        <p14:creationId xmlns:p14="http://schemas.microsoft.com/office/powerpoint/2010/main" val="1369000508"/>
+      </p:ext>
+    </p:extLst>
+  </p:cSld>
+  <p:clrMapOvr>
+    <a:masterClrMapping/>
+  </p:clrMapOvr>
+</p:sld>
+</file>
+
 <file path=ppt/slides/slide3.xml><?xml version="1.0" encoding="utf-8"?>
 <p:sld xmlns:a="http://schemas.openxmlformats.org/drawingml/2006/main" xmlns:r="http://schemas.openxmlformats.org/officeDocument/2006/relationships" xmlns:p="http://schemas.openxmlformats.org/presentationml/2006/main">
   <p:cSld>
@@ -12006,20 +12425,20 @@
 </file>
 
 <file path=customXml/item1.xml><?xml version="1.0" encoding="utf-8"?>
-<p:properties xmlns:p="http://schemas.microsoft.com/office/2006/metadata/properties" xmlns:xsi="http://www.w3.org/2001/XMLSchema-instance" xmlns:pc="http://schemas.microsoft.com/office/infopath/2007/PartnerControls">
-  <documentManagement>
-    <_activity xmlns="73ecfec2-fe59-4214-9cad-f553ff4d189b" xsi:nil="true"/>
-  </documentManagement>
-</p:properties>
-</file>
-
-<file path=customXml/item2.xml><?xml version="1.0" encoding="utf-8"?>
 <?mso-contentType ?>
 <FormTemplates xmlns="http://schemas.microsoft.com/sharepoint/v3/contenttype/forms">
   <Display>DocumentLibraryForm</Display>
   <Edit>DocumentLibraryForm</Edit>
   <New>DocumentLibraryForm</New>
 </FormTemplates>
+</file>
+
+<file path=customXml/item2.xml><?xml version="1.0" encoding="utf-8"?>
+<p:properties xmlns:p="http://schemas.microsoft.com/office/2006/metadata/properties" xmlns:xsi="http://www.w3.org/2001/XMLSchema-instance" xmlns:pc="http://schemas.microsoft.com/office/infopath/2007/PartnerControls">
+  <documentManagement>
+    <_activity xmlns="73ecfec2-fe59-4214-9cad-f553ff4d189b" xsi:nil="true"/>
+  </documentManagement>
+</p:properties>
 </file>
 
 <file path=customXml/item3.xml><?xml version="1.0" encoding="utf-8"?>
@@ -12173,6 +12592,14 @@
 </file>
 
 <file path=customXml/itemProps1.xml><?xml version="1.0" encoding="utf-8"?>
+<ds:datastoreItem xmlns:ds="http://schemas.openxmlformats.org/officeDocument/2006/customXml" ds:itemID="{75669B48-8959-4D7D-9AAA-BC16556B4A29}">
+  <ds:schemaRefs>
+    <ds:schemaRef ds:uri="http://schemas.microsoft.com/sharepoint/v3/contenttype/forms"/>
+  </ds:schemaRefs>
+</ds:datastoreItem>
+</file>
+
+<file path=customXml/itemProps2.xml><?xml version="1.0" encoding="utf-8"?>
 <ds:datastoreItem xmlns:ds="http://schemas.openxmlformats.org/officeDocument/2006/customXml" ds:itemID="{A0607A6D-E8B8-4AA3-9E0C-8E15E1BEA06E}">
   <ds:schemaRefs>
     <ds:schemaRef ds:uri="http://purl.org/dc/terms/"/>
@@ -12184,14 +12611,6 @@
     <ds:schemaRef ds:uri="http://schemas.microsoft.com/office/infopath/2007/PartnerControls"/>
     <ds:schemaRef ds:uri="73ecfec2-fe59-4214-9cad-f553ff4d189b"/>
     <ds:schemaRef ds:uri="http://purl.org/dc/dcmitype/"/>
-  </ds:schemaRefs>
-</ds:datastoreItem>
-</file>
-
-<file path=customXml/itemProps2.xml><?xml version="1.0" encoding="utf-8"?>
-<ds:datastoreItem xmlns:ds="http://schemas.openxmlformats.org/officeDocument/2006/customXml" ds:itemID="{75669B48-8959-4D7D-9AAA-BC16556B4A29}">
-  <ds:schemaRefs>
-    <ds:schemaRef ds:uri="http://schemas.microsoft.com/sharepoint/v3/contenttype/forms"/>
   </ds:schemaRefs>
 </ds:datastoreItem>
 </file>

</xml_diff>